<commit_message>
feat: restructure OutlineBlueprint to separate rich text document with placeholders from explicit block constraints for better Notion-like WYSIWYG experience
</commit_message>
<xml_diff>
--- a/output/outline_compiler.pptx
+++ b/output/outline_compiler.pptx
@@ -3388,21 +3388,24 @@
                 <a:latin typeface="Consolas"/>
               </a:rPr>
               <a:t>outline:
-  - id: "blk_intro"
-    type: "paragraph"
-    content: "当前设备主轴承的..."
-  # [UI 强制组件: 填入一个数值]
-  - id: "blk_metric_vib"
-    type: "metric"
-    intent: "查询设备当前最近一次..."
-  # [UI 强制组件: AI 测评]
-  - id: "blk_ai_diag"
-    type: "ai_summary"
-    intent: "评估是否存在风险,伴随轻微漏油"
-  # [UI 强制组件: 一个图表壳子]
-  - id: "blk_chart_trend"
-    type: "chart"
-    intent: "近 3 天的振动趋势折线图" </a:t>
+  # [富文本流骨架]
+  document: |
+    运行情况。当前振幅为：
+    {@blk_metric_vib}。
+    诊断结论如下：
+    {@blk_ai_diag}
+    趋势图：{@blk_chart_trend}
+  # [意图槽字典]
+  blocks:
+    - id: "blk_metric_vib"
+      type: "metric"
+      intent: "最近一次的振动幅值"
+    - id: "blk_ai_diag"
+      type: "ai_summary"
+      intent: "评估风险, 提示漏油"
+    - id: "blk_chart_trend"
+      type: "chart"
+      intent: "近 3 天的振动折线图" </a:t>
             </a:r>
           </a:p>
         </p:txBody>

</xml_diff>

<commit_message>
refactor: blocks are now intent parameters (indicator/time_range/scope/free_text) not presentation types; Agent autonomously decides how to present
</commit_message>
<xml_diff>
--- a/output/outline_compiler.pptx
+++ b/output/outline_compiler.pptx
@@ -3204,7 +3204,7 @@
                 </a:solidFill>
                 <a:latin typeface="微软雅黑"/>
               </a:rPr>
-              <a:t>报告大纲架构重塑：基于 Notion 蓝图的单向编译器模式</a:t>
+              <a:t>报告大纲架构：参数化意图 → Agent 自主编译 → 底层执行骨架</a:t>
             </a:r>
           </a:p>
         </p:txBody>
@@ -3239,7 +3239,7 @@
                 </a:solidFill>
                 <a:latin typeface="微软雅黑"/>
               </a:rPr>
-              <a:t>大纲（Outline）不再是生成结果厚的快照，而是严谨的意图区块集合，作为向底层执行层编译的源头指令</a:t>
+              <a:t>大纲只描述「意图的可变参数」(分析哪个指标/看什么时段/补充什么观察)，Agent 自主决定「如何展现」(图表/表格/文本)</a:t>
             </a:r>
           </a:p>
         </p:txBody>
@@ -3274,7 +3274,7 @@
                 </a:solidFill>
                 <a:latin typeface="微软雅黑"/>
               </a:rPr>
-              <a:t>第一层：大纲蓝图层 (YAML `outline`)</a:t>
+              <a:t>第一层：参数化意图大纲 (outline)</a:t>
             </a:r>
           </a:p>
         </p:txBody>
@@ -3309,7 +3309,7 @@
                 </a:solidFill>
                 <a:latin typeface="微软雅黑"/>
               </a:rPr>
-              <a:t>UI 所见即所得编辑。不含任何数据库真实数据，纯粹由指令意图构成的大纲结构（Blueprint）。</a:t>
+              <a:t>用户看到的是一句连贯的话，带可调参数插槽。完全不涉及任何展现形式（图表/表格）的决定。</a:t>
             </a:r>
           </a:p>
         </p:txBody>
@@ -3359,110 +3359,20 @@
       </p:sp>
       <p:sp>
         <p:nvSpPr>
-          <p:cNvPr id="9" name="TextBox 8"/>
-          <p:cNvSpPr txBox="1"/>
+          <p:cNvPr id="9" name="Rectangle 8"/>
+          <p:cNvSpPr/>
           <p:nvPr/>
         </p:nvSpPr>
         <p:spPr>
           <a:xfrm>
-            <a:off x="432000" y="1584000"/>
-            <a:ext cx="4176000" cy="4860000"/>
+            <a:off x="468000" y="3131999"/>
+            <a:ext cx="4104000" cy="396000"/>
           </a:xfrm>
           <a:prstGeom prst="rect">
             <a:avLst/>
           </a:prstGeom>
-          <a:noFill/>
-        </p:spPr>
-        <p:txBody>
-          <a:bodyPr wrap="square">
-            <a:spAutoFit/>
-          </a:bodyPr>
-          <a:lstStyle/>
-          <a:p>
-            <a:pPr algn="l"/>
-            <a:r>
-              <a:rPr sz="900" b="0">
-                <a:solidFill>
-                  <a:srgbClr val="2E2E2E"/>
-                </a:solidFill>
-                <a:latin typeface="Consolas"/>
-              </a:rPr>
-              <a:t>outline:
-  # [富文本流骨架]
-  document: |
-    运行情况。当前振幅为：
-    {@blk_metric_vib}。
-    诊断结论如下：
-    {@blk_ai_diag}
-    趋势图：{@blk_chart_trend}
-  # [意图槽字典]
-  blocks:
-    - id: "blk_metric_vib"
-      type: "metric"
-      intent: "最近一次的振动幅值"
-    - id: "blk_ai_diag"
-      type: "ai_summary"
-      intent: "评估风险, 提示漏油"
-    - id: "blk_chart_trend"
-      type: "chart"
-      intent: "近 3 天的振动折线图" </a:t>
-            </a:r>
-          </a:p>
-        </p:txBody>
-      </p:sp>
-      <p:sp>
-        <p:nvSpPr>
-          <p:cNvPr id="10" name="TextBox 9"/>
-          <p:cNvSpPr txBox="1"/>
-          <p:nvPr/>
-        </p:nvSpPr>
-        <p:spPr>
-          <a:xfrm>
-            <a:off x="5040000" y="3060000"/>
-            <a:ext cx="1440000" cy="288000"/>
-          </a:xfrm>
-          <a:prstGeom prst="rect">
-            <a:avLst/>
-          </a:prstGeom>
-          <a:noFill/>
-        </p:spPr>
-        <p:txBody>
-          <a:bodyPr wrap="square">
-            <a:spAutoFit/>
-          </a:bodyPr>
-          <a:lstStyle/>
-          <a:p>
-            <a:pPr algn="ctr"/>
-            <a:r>
-              <a:rPr sz="1000" b="1">
-                <a:solidFill>
-                  <a:srgbClr val="C7000F"/>
-                </a:solidFill>
-                <a:latin typeface="微软雅黑"/>
-              </a:rPr>
-              <a:t>Agent (Template Copilot)
-降维翻译与架构生成
-（保存时刻发生）</a:t>
-            </a:r>
-          </a:p>
-        </p:txBody>
-      </p:sp>
-      <p:sp>
-        <p:nvSpPr>
-          <p:cNvPr id="11" name="Right Arrow 10"/>
-          <p:cNvSpPr/>
-          <p:nvPr/>
-        </p:nvSpPr>
-        <p:spPr>
-          <a:xfrm>
-            <a:off x="5220000" y="3420000"/>
-            <a:ext cx="1080000" cy="216000"/>
-          </a:xfrm>
-          <a:prstGeom prst="rightArrow">
-            <a:avLst/>
-          </a:prstGeom>
           <a:solidFill>
-            <a:srgbClr val="C7000F"/>
+            <a:srgbClr val="E3F2FD"/>
           </a:solidFill>
           <a:ln>
             <a:noFill/>
@@ -3492,90 +3402,20 @@
       </p:sp>
       <p:sp>
         <p:nvSpPr>
-          <p:cNvPr id="12" name="TextBox 11"/>
-          <p:cNvSpPr txBox="1"/>
-          <p:nvPr/>
-        </p:nvSpPr>
-        <p:spPr>
-          <a:xfrm>
-            <a:off x="6840000" y="900000"/>
-            <a:ext cx="4680000" cy="180000"/>
-          </a:xfrm>
-          <a:prstGeom prst="rect">
-            <a:avLst/>
-          </a:prstGeom>
-          <a:noFill/>
-        </p:spPr>
-        <p:txBody>
-          <a:bodyPr wrap="square">
-            <a:spAutoFit/>
-          </a:bodyPr>
-          <a:lstStyle/>
-          <a:p>
-            <a:pPr algn="ctr"/>
-            <a:r>
-              <a:rPr sz="1400" b="1">
-                <a:solidFill>
-                  <a:srgbClr val="C7000F"/>
-                </a:solidFill>
-                <a:latin typeface="微软雅黑"/>
-              </a:rPr>
-              <a:t>第二层：底层骨架层 (YAML `content`)</a:t>
-            </a:r>
-          </a:p>
-        </p:txBody>
-      </p:sp>
-      <p:sp>
-        <p:nvSpPr>
-          <p:cNvPr id="13" name="TextBox 12"/>
-          <p:cNvSpPr txBox="1"/>
-          <p:nvPr/>
-        </p:nvSpPr>
-        <p:spPr>
-          <a:xfrm>
-            <a:off x="6840000" y="1152000"/>
-            <a:ext cx="4680000" cy="288000"/>
-          </a:xfrm>
-          <a:prstGeom prst="rect">
-            <a:avLst/>
-          </a:prstGeom>
-          <a:noFill/>
-        </p:spPr>
-        <p:txBody>
-          <a:bodyPr wrap="square">
-            <a:spAutoFit/>
-          </a:bodyPr>
-          <a:lstStyle/>
-          <a:p>
-            <a:pPr algn="l"/>
-            <a:r>
-              <a:rPr sz="850" b="0">
-                <a:solidFill>
-                  <a:srgbClr val="2E2E2E"/>
-                </a:solidFill>
-                <a:latin typeface="微软雅黑"/>
-              </a:rPr>
-              <a:t>编译成果（AST）。结构极为严谨，Data Engine 将以此为据，连接数据库跑批产生 8.5mm/s 这样的结果。</a:t>
-            </a:r>
-          </a:p>
-        </p:txBody>
-      </p:sp>
-      <p:sp>
-        <p:nvSpPr>
-          <p:cNvPr id="14" name="Rectangle 13"/>
+          <p:cNvPr id="10" name="Rectangle 9"/>
           <p:cNvSpPr/>
           <p:nvPr/>
         </p:nvSpPr>
         <p:spPr>
           <a:xfrm>
-            <a:off x="6840000" y="1548000"/>
-            <a:ext cx="4680000" cy="5040000"/>
+            <a:off x="468000" y="3780000"/>
+            <a:ext cx="4104000" cy="396000"/>
           </a:xfrm>
           <a:prstGeom prst="rect">
             <a:avLst/>
           </a:prstGeom>
           <a:solidFill>
-            <a:srgbClr val="F0F0F0"/>
+            <a:srgbClr val="E3F2FD"/>
           </a:solidFill>
           <a:ln>
             <a:noFill/>
@@ -3605,20 +3445,20 @@
       </p:sp>
       <p:sp>
         <p:nvSpPr>
-          <p:cNvPr id="15" name="Rectangle 14"/>
+          <p:cNvPr id="11" name="Rectangle 10"/>
           <p:cNvSpPr/>
           <p:nvPr/>
         </p:nvSpPr>
         <p:spPr>
           <a:xfrm>
-            <a:off x="6912000" y="2052000"/>
-            <a:ext cx="4536000" cy="432000"/>
+            <a:off x="468000" y="4428000"/>
+            <a:ext cx="4104000" cy="396000"/>
           </a:xfrm>
           <a:prstGeom prst="rect">
             <a:avLst/>
           </a:prstGeom>
           <a:solidFill>
-            <a:srgbClr val="FFE5E5"/>
+            <a:srgbClr val="E3F2FD"/>
           </a:solidFill>
           <a:ln>
             <a:noFill/>
@@ -3648,20 +3488,20 @@
       </p:sp>
       <p:sp>
         <p:nvSpPr>
-          <p:cNvPr id="16" name="Rectangle 15"/>
+          <p:cNvPr id="12" name="Rectangle 11"/>
           <p:cNvSpPr/>
           <p:nvPr/>
         </p:nvSpPr>
         <p:spPr>
           <a:xfrm>
-            <a:off x="6912000" y="2700000"/>
-            <a:ext cx="4536000" cy="432000"/>
+            <a:off x="468000" y="5076000"/>
+            <a:ext cx="4104000" cy="396000"/>
           </a:xfrm>
           <a:prstGeom prst="rect">
             <a:avLst/>
           </a:prstGeom>
           <a:solidFill>
-            <a:srgbClr val="FFE5E5"/>
+            <a:srgbClr val="E3F2FD"/>
           </a:solidFill>
           <a:ln>
             <a:noFill/>
@@ -3691,20 +3531,150 @@
       </p:sp>
       <p:sp>
         <p:nvSpPr>
-          <p:cNvPr id="17" name="Rectangle 16"/>
-          <p:cNvSpPr/>
+          <p:cNvPr id="13" name="TextBox 12"/>
+          <p:cNvSpPr txBox="1"/>
           <p:nvPr/>
         </p:nvSpPr>
         <p:spPr>
           <a:xfrm>
-            <a:off x="6912000" y="3348000"/>
-            <a:ext cx="4536000" cy="432000"/>
+            <a:off x="432000" y="1584000"/>
+            <a:ext cx="4176000" cy="4860000"/>
           </a:xfrm>
           <a:prstGeom prst="rect">
             <a:avLst/>
           </a:prstGeom>
+          <a:noFill/>
+        </p:spPr>
+        <p:txBody>
+          <a:bodyPr wrap="square">
+            <a:spAutoFit/>
+          </a:bodyPr>
+          <a:lstStyle/>
+          <a:p>
+            <a:pPr algn="l"/>
+            <a:r>
+              <a:rPr sz="850" b="0">
+                <a:solidFill>
+                  <a:srgbClr val="2E2E2E"/>
+                </a:solidFill>
+                <a:latin typeface="Consolas"/>
+              </a:rPr>
+              <a:t>outline:
+  # [连贯的意图描述]
+  document: |
+    对设备 {@target_device} 的
+    {@focus_metric} 进行深度分析。
+    分析范围为 {@analysis_period}。
+    如有异常,请结合
+    {@supplementary_context}
+    给出专业诊断建议。
+  # [意图的可变参数]
+  blocks:
+    - id: "target_device"
+      type: "param_ref"
+      default: "{$device}"
+    - id: "focus_metric"
+      type: "indicator"
+      default: "振动幅值"
+    - id: "analysis_period"
+      type: "time_range"
+      default: "近3天"
+    - id: "supplementary_context"
+      type: "free_text"
+      default: "端盖有轻微漏油" </a:t>
+            </a:r>
+          </a:p>
+        </p:txBody>
+      </p:sp>
+      <p:sp>
+        <p:nvSpPr>
+          <p:cNvPr id="14" name="TextBox 13"/>
+          <p:cNvSpPr txBox="1"/>
+          <p:nvPr/>
+        </p:nvSpPr>
+        <p:spPr>
+          <a:xfrm>
+            <a:off x="5040000" y="2520000"/>
+            <a:ext cx="1440000" cy="216000"/>
+          </a:xfrm>
+          <a:prstGeom prst="rect">
+            <a:avLst/>
+          </a:prstGeom>
+          <a:noFill/>
+        </p:spPr>
+        <p:txBody>
+          <a:bodyPr wrap="square">
+            <a:spAutoFit/>
+          </a:bodyPr>
+          <a:lstStyle/>
+          <a:p>
+            <a:pPr algn="ctr"/>
+            <a:r>
+              <a:rPr sz="900" b="1">
+                <a:solidFill>
+                  <a:srgbClr val="C7000F"/>
+                </a:solidFill>
+                <a:latin typeface="微软雅黑"/>
+              </a:rPr>
+              <a:t>Agent (Template Copilot)</a:t>
+            </a:r>
+          </a:p>
+        </p:txBody>
+      </p:sp>
+      <p:sp>
+        <p:nvSpPr>
+          <p:cNvPr id="15" name="TextBox 14"/>
+          <p:cNvSpPr txBox="1"/>
+          <p:nvPr/>
+        </p:nvSpPr>
+        <p:spPr>
+          <a:xfrm>
+            <a:off x="5040000" y="2808000"/>
+            <a:ext cx="1440000" cy="576000"/>
+          </a:xfrm>
+          <a:prstGeom prst="rect">
+            <a:avLst/>
+          </a:prstGeom>
+          <a:noFill/>
+        </p:spPr>
+        <p:txBody>
+          <a:bodyPr wrap="square">
+            <a:spAutoFit/>
+          </a:bodyPr>
+          <a:lstStyle/>
+          <a:p>
+            <a:pPr algn="ctr"/>
+            <a:r>
+              <a:rPr sz="800" b="0">
+                <a:solidFill>
+                  <a:srgbClr val="2E2E2E"/>
+                </a:solidFill>
+                <a:latin typeface="微软雅黑"/>
+              </a:rPr>
+              <a:t>通读整段意图
+自主决策：
+用什么数据源
+用什么展现形式</a:t>
+            </a:r>
+          </a:p>
+        </p:txBody>
+      </p:sp>
+      <p:sp>
+        <p:nvSpPr>
+          <p:cNvPr id="16" name="Right Arrow 15"/>
+          <p:cNvSpPr/>
+          <p:nvPr/>
+        </p:nvSpPr>
+        <p:spPr>
+          <a:xfrm>
+            <a:off x="5220000" y="3420000"/>
+            <a:ext cx="1080000" cy="216000"/>
+          </a:xfrm>
+          <a:prstGeom prst="rightArrow">
+            <a:avLst/>
+          </a:prstGeom>
           <a:solidFill>
-            <a:srgbClr val="FFE5E5"/>
+            <a:srgbClr val="C7000F"/>
           </a:solidFill>
           <a:ln>
             <a:noFill/>
@@ -3734,20 +3704,90 @@
       </p:sp>
       <p:sp>
         <p:nvSpPr>
-          <p:cNvPr id="18" name="Rectangle 17"/>
+          <p:cNvPr id="17" name="TextBox 16"/>
+          <p:cNvSpPr txBox="1"/>
+          <p:nvPr/>
+        </p:nvSpPr>
+        <p:spPr>
+          <a:xfrm>
+            <a:off x="6840000" y="900000"/>
+            <a:ext cx="4680000" cy="180000"/>
+          </a:xfrm>
+          <a:prstGeom prst="rect">
+            <a:avLst/>
+          </a:prstGeom>
+          <a:noFill/>
+        </p:spPr>
+        <p:txBody>
+          <a:bodyPr wrap="square">
+            <a:spAutoFit/>
+          </a:bodyPr>
+          <a:lstStyle/>
+          <a:p>
+            <a:pPr algn="ctr"/>
+            <a:r>
+              <a:rPr sz="1400" b="1">
+                <a:solidFill>
+                  <a:srgbClr val="C7000F"/>
+                </a:solidFill>
+                <a:latin typeface="微软雅黑"/>
+              </a:rPr>
+              <a:t>第二层：编译产物 (content)</a:t>
+            </a:r>
+          </a:p>
+        </p:txBody>
+      </p:sp>
+      <p:sp>
+        <p:nvSpPr>
+          <p:cNvPr id="18" name="TextBox 17"/>
+          <p:cNvSpPr txBox="1"/>
+          <p:nvPr/>
+        </p:nvSpPr>
+        <p:spPr>
+          <a:xfrm>
+            <a:off x="6840000" y="1152000"/>
+            <a:ext cx="4680000" cy="288000"/>
+          </a:xfrm>
+          <a:prstGeom prst="rect">
+            <a:avLst/>
+          </a:prstGeom>
+          <a:noFill/>
+        </p:spPr>
+        <p:txBody>
+          <a:bodyPr wrap="square">
+            <a:spAutoFit/>
+          </a:bodyPr>
+          <a:lstStyle/>
+          <a:p>
+            <a:pPr algn="l"/>
+            <a:r>
+              <a:rPr sz="850" b="0">
+                <a:solidFill>
+                  <a:srgbClr val="2E2E2E"/>
+                </a:solidFill>
+                <a:latin typeface="微软雅黑"/>
+              </a:rPr>
+              <a:t>Agent 自主选择的数据源和展现方式。用户没有指定任何图表类型——全是 Agent 编译产物。</a:t>
+            </a:r>
+          </a:p>
+        </p:txBody>
+      </p:sp>
+      <p:sp>
+        <p:nvSpPr>
+          <p:cNvPr id="19" name="Rectangle 18"/>
           <p:cNvSpPr/>
           <p:nvPr/>
         </p:nvSpPr>
         <p:spPr>
           <a:xfrm>
-            <a:off x="6912000" y="5472000"/>
-            <a:ext cx="4536000" cy="540000"/>
+            <a:off x="6840000" y="1548000"/>
+            <a:ext cx="4680000" cy="5040000"/>
           </a:xfrm>
           <a:prstGeom prst="rect">
             <a:avLst/>
           </a:prstGeom>
           <a:solidFill>
-            <a:srgbClr val="FFE5E5"/>
+            <a:srgbClr val="F0F0F0"/>
           </a:solidFill>
           <a:ln>
             <a:noFill/>
@@ -3777,7 +3817,179 @@
       </p:sp>
       <p:sp>
         <p:nvSpPr>
-          <p:cNvPr id="19" name="TextBox 18"/>
+          <p:cNvPr id="20" name="Rectangle 19"/>
+          <p:cNvSpPr/>
+          <p:nvPr/>
+        </p:nvSpPr>
+        <p:spPr>
+          <a:xfrm>
+            <a:off x="6948000" y="1980000"/>
+            <a:ext cx="4464000" cy="900000"/>
+          </a:xfrm>
+          <a:prstGeom prst="rect">
+            <a:avLst/>
+          </a:prstGeom>
+          <a:solidFill>
+            <a:srgbClr val="FFE5E5"/>
+          </a:solidFill>
+          <a:ln>
+            <a:noFill/>
+          </a:ln>
+        </p:spPr>
+        <p:style>
+          <a:lnRef idx="1">
+            <a:schemeClr val="accent1"/>
+          </a:lnRef>
+          <a:fillRef idx="3">
+            <a:schemeClr val="accent1"/>
+          </a:fillRef>
+          <a:effectRef idx="2">
+            <a:schemeClr val="accent1"/>
+          </a:effectRef>
+          <a:fontRef idx="minor">
+            <a:schemeClr val="lt1"/>
+          </a:fontRef>
+        </p:style>
+        <p:txBody>
+          <a:bodyPr rtlCol="0" anchor="ctr"/>
+          <a:lstStyle/>
+          <a:p>
+            <a:pPr algn="ctr"/>
+          </a:p>
+        </p:txBody>
+      </p:sp>
+      <p:sp>
+        <p:nvSpPr>
+          <p:cNvPr id="21" name="Rectangle 20"/>
+          <p:cNvSpPr/>
+          <p:nvPr/>
+        </p:nvSpPr>
+        <p:spPr>
+          <a:xfrm>
+            <a:off x="6948000" y="3096000"/>
+            <a:ext cx="4464000" cy="720000"/>
+          </a:xfrm>
+          <a:prstGeom prst="rect">
+            <a:avLst/>
+          </a:prstGeom>
+          <a:solidFill>
+            <a:srgbClr val="FFE5E5"/>
+          </a:solidFill>
+          <a:ln>
+            <a:noFill/>
+          </a:ln>
+        </p:spPr>
+        <p:style>
+          <a:lnRef idx="1">
+            <a:schemeClr val="accent1"/>
+          </a:lnRef>
+          <a:fillRef idx="3">
+            <a:schemeClr val="accent1"/>
+          </a:fillRef>
+          <a:effectRef idx="2">
+            <a:schemeClr val="accent1"/>
+          </a:effectRef>
+          <a:fontRef idx="minor">
+            <a:schemeClr val="lt1"/>
+          </a:fontRef>
+        </p:style>
+        <p:txBody>
+          <a:bodyPr rtlCol="0" anchor="ctr"/>
+          <a:lstStyle/>
+          <a:p>
+            <a:pPr algn="ctr"/>
+          </a:p>
+        </p:txBody>
+      </p:sp>
+      <p:sp>
+        <p:nvSpPr>
+          <p:cNvPr id="22" name="Rectangle 21"/>
+          <p:cNvSpPr/>
+          <p:nvPr/>
+        </p:nvSpPr>
+        <p:spPr>
+          <a:xfrm>
+            <a:off x="6948000" y="4031999"/>
+            <a:ext cx="4464000" cy="900000"/>
+          </a:xfrm>
+          <a:prstGeom prst="rect">
+            <a:avLst/>
+          </a:prstGeom>
+          <a:solidFill>
+            <a:srgbClr val="FFE5E5"/>
+          </a:solidFill>
+          <a:ln>
+            <a:noFill/>
+          </a:ln>
+        </p:spPr>
+        <p:style>
+          <a:lnRef idx="1">
+            <a:schemeClr val="accent1"/>
+          </a:lnRef>
+          <a:fillRef idx="3">
+            <a:schemeClr val="accent1"/>
+          </a:fillRef>
+          <a:effectRef idx="2">
+            <a:schemeClr val="accent1"/>
+          </a:effectRef>
+          <a:fontRef idx="minor">
+            <a:schemeClr val="lt1"/>
+          </a:fontRef>
+        </p:style>
+        <p:txBody>
+          <a:bodyPr rtlCol="0" anchor="ctr"/>
+          <a:lstStyle/>
+          <a:p>
+            <a:pPr algn="ctr"/>
+          </a:p>
+        </p:txBody>
+      </p:sp>
+      <p:sp>
+        <p:nvSpPr>
+          <p:cNvPr id="23" name="Rectangle 22"/>
+          <p:cNvSpPr/>
+          <p:nvPr/>
+        </p:nvSpPr>
+        <p:spPr>
+          <a:xfrm>
+            <a:off x="6948000" y="5508000"/>
+            <a:ext cx="4464000" cy="900000"/>
+          </a:xfrm>
+          <a:prstGeom prst="rect">
+            <a:avLst/>
+          </a:prstGeom>
+          <a:solidFill>
+            <a:srgbClr val="FFE5E5"/>
+          </a:solidFill>
+          <a:ln>
+            <a:noFill/>
+          </a:ln>
+        </p:spPr>
+        <p:style>
+          <a:lnRef idx="1">
+            <a:schemeClr val="accent1"/>
+          </a:lnRef>
+          <a:fillRef idx="3">
+            <a:schemeClr val="accent1"/>
+          </a:fillRef>
+          <a:effectRef idx="2">
+            <a:schemeClr val="accent1"/>
+          </a:effectRef>
+          <a:fontRef idx="minor">
+            <a:schemeClr val="lt1"/>
+          </a:fontRef>
+        </p:style>
+        <p:txBody>
+          <a:bodyPr rtlCol="0" anchor="ctr"/>
+          <a:lstStyle/>
+          <a:p>
+            <a:pPr algn="ctr"/>
+          </a:p>
+        </p:txBody>
+      </p:sp>
+      <p:sp>
+        <p:nvSpPr>
+          <p:cNvPr id="24" name="TextBox 23"/>
           <p:cNvSpPr txBox="1"/>
           <p:nvPr/>
         </p:nvSpPr>
@@ -3799,7 +4011,7 @@
           <a:p>
             <a:pPr algn="l"/>
             <a:r>
-              <a:rPr sz="900" b="0">
+              <a:rPr sz="850" b="0">
                 <a:solidFill>
                   <a:srgbClr val="2E2E2E"/>
                 </a:solidFill>
@@ -3807,23 +4019,24 @@
               </a:rPr>
               <a:t>content:
   datasets:
-    # 响应 blk_metric_vib 意图
-    - id: "ds_metric_vib"
-      source: { kind: nl2sql, desc: "查最近一次振幅" }
-    # 响应 blk_chart_trend 意图
-    - id: "ds_trend_chart"
-      source: { kind: nl2sql, desc: "查近3天振幅" }
-    # 响应 blk_ai_diag 意图
-    - id: "ds_synthesis" ...
-      source: { kind: ai_synthesis, prompt: "轻微漏油" }
+    # Agent 自主决定需要 3 个数据源
+    - id: "ds_vib_current"
+      source: { kind: nl2sql }
+      desc: "查设备最近一次振幅"
+    - id: "ds_vib_trend"
+      source: { kind: nl2sql }
+      desc: "查近3天振幅历史"
+    - id: "ds_diagnosis"
+      source: { kind: ai_synthesis }
+      prompt: "分析+漏油事实"
   presentation:
+    # Agent 自主决定排版方案
     type: composite_table
     sections:
-      - band: "振动诊断结论"
-        layout: { type: mixed_text, dataset_id: "ds_synthesis" }
-      # 响应 blk_chart_trend 配备的 UI 壳子
-      - band: "辅助分析趋势图"
-        layout: { type: chart, chart_type: "line", dataset_id: "ds_trend_chart" } </a:t>
+      - band: "诊断结论"
+        layout: kv_grid
+      - band: "趋势图"      
+        layout: chart(line) </a:t>
             </a:r>
           </a:p>
         </p:txBody>

</xml_diff>

<commit_message>
feat: expand OutlineBlock parameter types (threshold, operator, enum_select, number, boolean) and update examples/PPT to sync
</commit_message>
<xml_diff>
--- a/output/outline_compiler.pptx
+++ b/output/outline_compiler.pptx
@@ -3365,8 +3365,8 @@
         </p:nvSpPr>
         <p:spPr>
           <a:xfrm>
-            <a:off x="468000" y="3131999"/>
-            <a:ext cx="4104000" cy="396000"/>
+            <a:off x="468000" y="3348000"/>
+            <a:ext cx="4104000" cy="324000"/>
           </a:xfrm>
           <a:prstGeom prst="rect">
             <a:avLst/>
@@ -3409,7 +3409,7 @@
         <p:spPr>
           <a:xfrm>
             <a:off x="468000" y="3780000"/>
-            <a:ext cx="4104000" cy="396000"/>
+            <a:ext cx="4104000" cy="324000"/>
           </a:xfrm>
           <a:prstGeom prst="rect">
             <a:avLst/>
@@ -3451,8 +3451,8 @@
         </p:nvSpPr>
         <p:spPr>
           <a:xfrm>
-            <a:off x="468000" y="4428000"/>
-            <a:ext cx="4104000" cy="396000"/>
+            <a:off x="468000" y="4212000"/>
+            <a:ext cx="4104000" cy="324000"/>
           </a:xfrm>
           <a:prstGeom prst="rect">
             <a:avLst/>
@@ -3494,8 +3494,8 @@
         </p:nvSpPr>
         <p:spPr>
           <a:xfrm>
-            <a:off x="468000" y="5076000"/>
-            <a:ext cx="4104000" cy="396000"/>
+            <a:off x="468000" y="4680000"/>
+            <a:ext cx="4104000" cy="324000"/>
           </a:xfrm>
           <a:prstGeom prst="rect">
             <a:avLst/>
@@ -3565,23 +3565,24 @@
     对设备 {@target_device} 的
     {@focus_metric} 进行深度分析。
     分析范围为 {@analysis_period}。
+    重点关注是否 {@cmp} {@thres}。
     如有异常,请结合
     {@supplementary_context}
     给出专业诊断建议。
   # [意图的可变参数]
   blocks:
-    - id: "target_device"
-      type: "param_ref"
-      default: "{$device}"
     - id: "focus_metric"
       type: "indicator"
       default: "振动幅值"
     - id: "analysis_period"
       type: "time_range"
       default: "近3天"
-    - id: "supplementary_context"
-      type: "free_text"
-      default: "端盖有轻微漏油" </a:t>
+    - id: "cmp"
+      type: "operator"
+      default: "大于"
+    - id: "thres"
+      type: "threshold"
+      default: "8.5mm/s" </a:t>
             </a:r>
           </a:p>
         </p:txBody>

</xml_diff>